<commit_message>
Improve presentation slides with clear source attributions
Update presentation script to include precise source attributions for numerical data and methodology references in `create_presentation.py`. Update `replit.md` for course and project details.

Replit-Commit-Author: Agent
Replit-Commit-Session-Id: d1af01ac-c843-4bff-a7a9-fedef4198273
Replit-Commit-Checkpoint-Type: intermediate_checkpoint
Replit-Commit-Event-Id: a681147d-7fd8-4e40-8f23-55afeb1a21e5
Replit-Helium-Checkpoint-Created: true
</commit_message>
<xml_diff>
--- a/Factor_Analysis_Presentation.pptx
+++ b/Factor_Analysis_Presentation.pptx
@@ -3460,7 +3460,7 @@
               </a:defRPr>
             </a:pPr>
             <a:r>
-              <a:t>Results from Shrestha (2021):</a:t>
+              <a:t>Results (Shrestha, 2021; DOI: 10.12691/ajams-9-1-2):</a:t>
             </a:r>
           </a:p>
           <a:p>
@@ -3496,7 +3496,7 @@
               </a:defRPr>
             </a:pPr>
             <a:r>
-              <a:t>    Chi-Square = 637.65,    Significance: p &lt; 0.0001</a:t>
+              <a:t>    Chi-Square = 637.65,    df = 55,    Significance: p &lt; 0.0001</a:t>
             </a:r>
           </a:p>
           <a:p>
@@ -3641,6 +3641,33 @@
               <a:spcAft>
                 <a:spcPts val="600"/>
               </a:spcAft>
+              <a:defRPr sz="1100" b="1">
+                <a:solidFill>
+                  <a:srgbClr val="0070C0"/>
+                </a:solidFill>
+              </a:defRPr>
+            </a:pPr>
+            <a:r>
+              <a:t>Source: Malhotra (2010)</a:t>
+            </a:r>
+          </a:p>
+          <a:p>
+            <a:pPr>
+              <a:spcAft>
+                <a:spcPts val="600"/>
+              </a:spcAft>
+              <a:defRPr sz="1200">
+                <a:solidFill>
+                  <a:srgbClr val="323232"/>
+                </a:solidFill>
+              </a:defRPr>
+            </a:pPr>
+          </a:p>
+          <a:p>
+            <a:pPr>
+              <a:spcAft>
+                <a:spcPts val="600"/>
+              </a:spcAft>
               <a:defRPr sz="1500" b="1">
                 <a:solidFill>
                   <a:srgbClr val="002060"/>
@@ -3871,6 +3898,18 @@
             </a:pPr>
             <a:r>
               <a:t>Step 4: Eigenvalues &amp; Total Variance Explained</a:t>
+            </a:r>
+          </a:p>
+          <a:p>
+            <a:pPr algn="l">
+              <a:defRPr sz="1400">
+                <a:solidFill>
+                  <a:srgbClr val="FFC000"/>
+                </a:solidFill>
+              </a:defRPr>
+            </a:pPr>
+            <a:r>
+              <a:t>Source: Malhotra (2010)</a:t>
             </a:r>
           </a:p>
         </p:txBody>
@@ -4793,6 +4832,33 @@
               <a:spcAft>
                 <a:spcPts val="600"/>
               </a:spcAft>
+              <a:defRPr sz="1100" b="1">
+                <a:solidFill>
+                  <a:srgbClr val="0070C0"/>
+                </a:solidFill>
+              </a:defRPr>
+            </a:pPr>
+            <a:r>
+              <a:t>Source: Malhotra (2010)</a:t>
+            </a:r>
+          </a:p>
+          <a:p>
+            <a:pPr>
+              <a:spcAft>
+                <a:spcPts val="600"/>
+              </a:spcAft>
+              <a:defRPr sz="1400">
+                <a:solidFill>
+                  <a:srgbClr val="323232"/>
+                </a:solidFill>
+              </a:defRPr>
+            </a:pPr>
+          </a:p>
+          <a:p>
+            <a:pPr>
+              <a:spcAft>
+                <a:spcPts val="600"/>
+              </a:spcAft>
               <a:defRPr sz="1600" b="1">
                 <a:solidFill>
                   <a:srgbClr val="004080"/>
@@ -9739,6 +9805,33 @@
               <a:spcAft>
                 <a:spcPts val="600"/>
               </a:spcAft>
+              <a:defRPr sz="1100" b="1">
+                <a:solidFill>
+                  <a:srgbClr val="0070C0"/>
+                </a:solidFill>
+              </a:defRPr>
+            </a:pPr>
+            <a:r>
+              <a:t>Source: Malhotra (2010)</a:t>
+            </a:r>
+          </a:p>
+          <a:p>
+            <a:pPr>
+              <a:spcAft>
+                <a:spcPts val="600"/>
+              </a:spcAft>
+              <a:defRPr sz="1300">
+                <a:solidFill>
+                  <a:srgbClr val="323232"/>
+                </a:solidFill>
+              </a:defRPr>
+            </a:pPr>
+          </a:p>
+          <a:p>
+            <a:pPr>
+              <a:spcAft>
+                <a:spcPts val="600"/>
+              </a:spcAft>
               <a:defRPr sz="1500" b="1">
                 <a:solidFill>
                   <a:srgbClr val="002060"/>

</xml_diff>